<commit_message>
docs(presentation): add interactive web slide viewer and XML-validated PPTX presentation
</commit_message>
<xml_diff>
--- a/Satellite_Flood_Risk_Monitor_Presentation.pptx
+++ b/Satellite_Flood_Risk_Monitor_Presentation.pptx
@@ -6,17 +6,17 @@
   </p:sldMasterIdLst>
   <p:sldIdLst>
     <p:sldId id="256" r:id="rId7"/>
-    <p:sldId id="257" r:id="rId9"/>
-    <p:sldId id="258" r:id="rId10"/>
-    <p:sldId id="259" r:id="rId11"/>
-    <p:sldId id="260" r:id="rId12"/>
-    <p:sldId id="261" r:id="rId13"/>
-    <p:sldId id="262" r:id="rId14"/>
-    <p:sldId id="263" r:id="rId15"/>
-    <p:sldId id="264" r:id="rId16"/>
-    <p:sldId id="265" r:id="rId17"/>
-    <p:sldId id="266" r:id="rId18"/>
-    <p:sldId id="267" r:id="rId19"/>
+    <p:sldId id="257" r:id="rId8"/>
+    <p:sldId id="258" r:id="rId9"/>
+    <p:sldId id="259" r:id="rId10"/>
+    <p:sldId id="260" r:id="rId11"/>
+    <p:sldId id="261" r:id="rId12"/>
+    <p:sldId id="262" r:id="rId13"/>
+    <p:sldId id="263" r:id="rId14"/>
+    <p:sldId id="264" r:id="rId15"/>
+    <p:sldId id="265" r:id="rId16"/>
+    <p:sldId id="266" r:id="rId17"/>
+    <p:sldId id="267" r:id="rId18"/>
   </p:sldIdLst>
   <p:sldSz cx="12191695" cy="6858000" type="screen4x3"/>
   <p:notesSz cx="6858000" cy="9144000"/>
@@ -116,1196 +116,6 @@
     </a:lvl9pPr>
   </p:defaultTextStyle>
 </p:presentation>
-</file>
-
-<file path=ppt/notesMasters/notesMaster1.xml><?xml version="1.0" encoding="utf-8"?>
-<p:notesMaster xmlns:a="http://schemas.openxmlformats.org/drawingml/2006/main" xmlns:p="http://schemas.openxmlformats.org/presentationml/2006/main" xmlns:r="http://schemas.openxmlformats.org/officeDocument/2006/relationships">
-  <p:cSld>
-    <p:bg>
-      <p:bgRef idx="1001">
-        <a:schemeClr val="bg1"/>
-      </p:bgRef>
-    </p:bg>
-    <p:spTree>
-      <p:nvGrpSpPr>
-        <p:cNvPr id="1" name=""/>
-        <p:cNvGrpSpPr/>
-        <p:nvPr/>
-      </p:nvGrpSpPr>
-      <p:grpSpPr>
-        <a:xfrm>
-          <a:off x="0" y="0"/>
-          <a:ext cx="0" cy="0"/>
-          <a:chOff x="0" y="0"/>
-          <a:chExt cx="0" cy="0"/>
-        </a:xfrm>
-      </p:grpSpPr>
-      <p:sp>
-        <p:nvSpPr>
-          <p:cNvPr id="2" name="Header Placeholder 1"/>
-          <p:cNvSpPr>
-            <a:spLocks noGrp="1"/>
-          </p:cNvSpPr>
-          <p:nvPr>
-            <p:ph type="hdr" sz="quarter"/>
-          </p:nvPr>
-        </p:nvSpPr>
-        <p:spPr>
-          <a:xfrm>
-            <a:off x="0" y="0"/>
-            <a:ext cx="2971800" cy="457200"/>
-          </a:xfrm>
-          <a:prstGeom prst="rect">
-            <a:avLst/>
-          </a:prstGeom>
-        </p:spPr>
-        <p:txBody>
-          <a:bodyPr vert="horz" lIns="91440" tIns="45720" rIns="91440" bIns="45720" rtlCol="0"/>
-          <a:lstStyle>
-            <a:lvl1pPr algn="l">
-              <a:defRPr sz="1200"/>
-            </a:lvl1pPr>
-          </a:lstStyle>
-          <a:p>
-            <a:endParaRPr lang="en-US"/>
-          </a:p>
-        </p:txBody>
-      </p:sp>
-      <p:sp>
-        <p:nvSpPr>
-          <p:cNvPr id="3" name="Date Placeholder 2"/>
-          <p:cNvSpPr>
-            <a:spLocks noGrp="1"/>
-          </p:cNvSpPr>
-          <p:nvPr>
-            <p:ph type="dt" idx="1"/>
-          </p:nvPr>
-        </p:nvSpPr>
-        <p:spPr>
-          <a:xfrm>
-            <a:off x="3884613" y="0"/>
-            <a:ext cx="2971800" cy="457200"/>
-          </a:xfrm>
-          <a:prstGeom prst="rect">
-            <a:avLst/>
-          </a:prstGeom>
-        </p:spPr>
-        <p:txBody>
-          <a:bodyPr vert="horz" lIns="91440" tIns="45720" rIns="91440" bIns="45720" rtlCol="0"/>
-          <a:lstStyle>
-            <a:lvl1pPr algn="r">
-              <a:defRPr sz="1200"/>
-            </a:lvl1pPr>
-          </a:lstStyle>
-          <a:p>
-            <a:fld id="{0F89C1C7-3DCD-1040-A9CF-14679D8B5DDD}" type="datetimeFigureOut">
-              <a:rPr lang="en-US" smtClean="0"/>
-              <a:t>10/17/16</a:t>
-            </a:fld>
-            <a:endParaRPr lang="en-US"/>
-          </a:p>
-        </p:txBody>
-      </p:sp>
-      <p:sp>
-        <p:nvSpPr>
-          <p:cNvPr id="4" name="Slide Image Placeholder 3"/>
-          <p:cNvSpPr>
-            <a:spLocks noGrp="1" noRot="1" noChangeAspect="1"/>
-          </p:cNvSpPr>
-          <p:nvPr>
-            <p:ph type="sldImg" idx="2"/>
-          </p:nvPr>
-        </p:nvSpPr>
-        <p:spPr>
-          <a:xfrm>
-            <a:off x="1143000" y="685800"/>
-            <a:ext cx="4572000" cy="3429000"/>
-          </a:xfrm>
-          <a:prstGeom prst="rect">
-            <a:avLst/>
-          </a:prstGeom>
-          <a:noFill/>
-          <a:ln w="12700">
-            <a:solidFill>
-              <a:prstClr val="black"/>
-            </a:solidFill>
-          </a:ln>
-        </p:spPr>
-        <p:txBody>
-          <a:bodyPr vert="horz" lIns="91440" tIns="45720" rIns="91440" bIns="45720" rtlCol="0" anchor="ctr"/>
-          <a:lstStyle/>
-          <a:p>
-            <a:endParaRPr lang="en-US"/>
-          </a:p>
-        </p:txBody>
-      </p:sp>
-      <p:sp>
-        <p:nvSpPr>
-          <p:cNvPr id="5" name="Notes Placeholder 4"/>
-          <p:cNvSpPr>
-            <a:spLocks noGrp="1"/>
-          </p:cNvSpPr>
-          <p:nvPr>
-            <p:ph type="body" sz="quarter" idx="3"/>
-          </p:nvPr>
-        </p:nvSpPr>
-        <p:spPr>
-          <a:xfrm>
-            <a:off x="685800" y="4343400"/>
-            <a:ext cx="5486400" cy="4114800"/>
-          </a:xfrm>
-          <a:prstGeom prst="rect">
-            <a:avLst/>
-          </a:prstGeom>
-        </p:spPr>
-        <p:txBody>
-          <a:bodyPr vert="horz" lIns="91440" tIns="45720" rIns="91440" bIns="45720" rtlCol="0"/>
-          <a:lstStyle/>
-          <a:p>
-            <a:pPr lvl="0"/>
-            <a:r>
-              <a:rPr lang="en-US" smtClean="0"/>
-              <a:t>Click to edit Master text styles</a:t>
-            </a:r>
-          </a:p>
-          <a:p>
-            <a:pPr lvl="1"/>
-            <a:r>
-              <a:rPr lang="en-US" smtClean="0"/>
-              <a:t>Second level</a:t>
-            </a:r>
-          </a:p>
-          <a:p>
-            <a:pPr lvl="2"/>
-            <a:r>
-              <a:rPr lang="en-US" smtClean="0"/>
-              <a:t>Third level</a:t>
-            </a:r>
-          </a:p>
-          <a:p>
-            <a:pPr lvl="3"/>
-            <a:r>
-              <a:rPr lang="en-US" smtClean="0"/>
-              <a:t>Fourth level</a:t>
-            </a:r>
-          </a:p>
-          <a:p>
-            <a:pPr lvl="4"/>
-            <a:r>
-              <a:rPr lang="en-US" smtClean="0"/>
-              <a:t>Fifth level</a:t>
-            </a:r>
-            <a:endParaRPr lang="en-US"/>
-          </a:p>
-        </p:txBody>
-      </p:sp>
-      <p:sp>
-        <p:nvSpPr>
-          <p:cNvPr id="6" name="Footer Placeholder 5"/>
-          <p:cNvSpPr>
-            <a:spLocks noGrp="1"/>
-          </p:cNvSpPr>
-          <p:nvPr>
-            <p:ph type="ftr" sz="quarter" idx="4"/>
-          </p:nvPr>
-        </p:nvSpPr>
-        <p:spPr>
-          <a:xfrm>
-            <a:off x="0" y="8685213"/>
-            <a:ext cx="2971800" cy="457200"/>
-          </a:xfrm>
-          <a:prstGeom prst="rect">
-            <a:avLst/>
-          </a:prstGeom>
-        </p:spPr>
-        <p:txBody>
-          <a:bodyPr vert="horz" lIns="91440" tIns="45720" rIns="91440" bIns="45720" rtlCol="0" anchor="b"/>
-          <a:lstStyle>
-            <a:lvl1pPr algn="l">
-              <a:defRPr sz="1200"/>
-            </a:lvl1pPr>
-          </a:lstStyle>
-          <a:p>
-            <a:endParaRPr lang="en-US"/>
-          </a:p>
-        </p:txBody>
-      </p:sp>
-      <p:sp>
-        <p:nvSpPr>
-          <p:cNvPr id="7" name="Slide Number Placeholder 6"/>
-          <p:cNvSpPr>
-            <a:spLocks noGrp="1"/>
-          </p:cNvSpPr>
-          <p:nvPr>
-            <p:ph type="sldNum" sz="quarter" idx="5"/>
-          </p:nvPr>
-        </p:nvSpPr>
-        <p:spPr>
-          <a:xfrm>
-            <a:off x="3884613" y="8685213"/>
-            <a:ext cx="2971800" cy="457200"/>
-          </a:xfrm>
-          <a:prstGeom prst="rect">
-            <a:avLst/>
-          </a:prstGeom>
-        </p:spPr>
-        <p:txBody>
-          <a:bodyPr vert="horz" lIns="91440" tIns="45720" rIns="91440" bIns="45720" rtlCol="0" anchor="b"/>
-          <a:lstStyle>
-            <a:lvl1pPr algn="r">
-              <a:defRPr sz="1200"/>
-            </a:lvl1pPr>
-          </a:lstStyle>
-          <a:p>
-            <a:fld id="{BB5E49A5-4136-284D-997B-48E1D791AD67}" type="slidenum">
-              <a:rPr lang="en-US" smtClean="0"/>
-              <a:t>‹#›</a:t>
-            </a:fld>
-            <a:endParaRPr lang="en-US"/>
-          </a:p>
-        </p:txBody>
-      </p:sp>
-    </p:spTree>
-    <p:extLst>
-      <p:ext uri="{BB962C8B-B14F-4D97-AF65-F5344CB8AC3E}">
-        <p14:creationId xmlns:p14="http://schemas.microsoft.com/office/powerpoint/2010/main" val="2623252185"/>
-      </p:ext>
-    </p:extLst>
-  </p:cSld>
-  <p:clrMap bg1="lt1" tx1="dk1" bg2="lt2" tx2="dk2" accent1="accent1" accent2="accent2" accent3="accent3" accent4="accent4" accent5="accent5" accent6="accent6" hlink="hlink" folHlink="folHlink"/>
-  <p:notesStyle>
-    <a:lvl1pPr marL="0" algn="l" defTabSz="457200" rtl="0" eaLnBrk="1" latinLnBrk="0" hangingPunct="1">
-      <a:defRPr sz="1200" kern="1200">
-        <a:solidFill>
-          <a:schemeClr val="tx1"/>
-        </a:solidFill>
-        <a:latin typeface="+mn-lt"/>
-        <a:ea typeface="+mn-ea"/>
-        <a:cs typeface="+mn-cs"/>
-      </a:defRPr>
-    </a:lvl1pPr>
-    <a:lvl2pPr marL="457200" algn="l" defTabSz="457200" rtl="0" eaLnBrk="1" latinLnBrk="0" hangingPunct="1">
-      <a:defRPr sz="1200" kern="1200">
-        <a:solidFill>
-          <a:schemeClr val="tx1"/>
-        </a:solidFill>
-        <a:latin typeface="+mn-lt"/>
-        <a:ea typeface="+mn-ea"/>
-        <a:cs typeface="+mn-cs"/>
-      </a:defRPr>
-    </a:lvl2pPr>
-    <a:lvl3pPr marL="914400" algn="l" defTabSz="457200" rtl="0" eaLnBrk="1" latinLnBrk="0" hangingPunct="1">
-      <a:defRPr sz="1200" kern="1200">
-        <a:solidFill>
-          <a:schemeClr val="tx1"/>
-        </a:solidFill>
-        <a:latin typeface="+mn-lt"/>
-        <a:ea typeface="+mn-ea"/>
-        <a:cs typeface="+mn-cs"/>
-      </a:defRPr>
-    </a:lvl3pPr>
-    <a:lvl4pPr marL="1371600" algn="l" defTabSz="457200" rtl="0" eaLnBrk="1" latinLnBrk="0" hangingPunct="1">
-      <a:defRPr sz="1200" kern="1200">
-        <a:solidFill>
-          <a:schemeClr val="tx1"/>
-        </a:solidFill>
-        <a:latin typeface="+mn-lt"/>
-        <a:ea typeface="+mn-ea"/>
-        <a:cs typeface="+mn-cs"/>
-      </a:defRPr>
-    </a:lvl4pPr>
-    <a:lvl5pPr marL="1828800" algn="l" defTabSz="457200" rtl="0" eaLnBrk="1" latinLnBrk="0" hangingPunct="1">
-      <a:defRPr sz="1200" kern="1200">
-        <a:solidFill>
-          <a:schemeClr val="tx1"/>
-        </a:solidFill>
-        <a:latin typeface="+mn-lt"/>
-        <a:ea typeface="+mn-ea"/>
-        <a:cs typeface="+mn-cs"/>
-      </a:defRPr>
-    </a:lvl5pPr>
-    <a:lvl6pPr marL="2286000" algn="l" defTabSz="457200" rtl="0" eaLnBrk="1" latinLnBrk="0" hangingPunct="1">
-      <a:defRPr sz="1200" kern="1200">
-        <a:solidFill>
-          <a:schemeClr val="tx1"/>
-        </a:solidFill>
-        <a:latin typeface="+mn-lt"/>
-        <a:ea typeface="+mn-ea"/>
-        <a:cs typeface="+mn-cs"/>
-      </a:defRPr>
-    </a:lvl6pPr>
-    <a:lvl7pPr marL="2743200" algn="l" defTabSz="457200" rtl="0" eaLnBrk="1" latinLnBrk="0" hangingPunct="1">
-      <a:defRPr sz="1200" kern="1200">
-        <a:solidFill>
-          <a:schemeClr val="tx1"/>
-        </a:solidFill>
-        <a:latin typeface="+mn-lt"/>
-        <a:ea typeface="+mn-ea"/>
-        <a:cs typeface="+mn-cs"/>
-      </a:defRPr>
-    </a:lvl7pPr>
-    <a:lvl8pPr marL="3200400" algn="l" defTabSz="457200" rtl="0" eaLnBrk="1" latinLnBrk="0" hangingPunct="1">
-      <a:defRPr sz="1200" kern="1200">
-        <a:solidFill>
-          <a:schemeClr val="tx1"/>
-        </a:solidFill>
-        <a:latin typeface="+mn-lt"/>
-        <a:ea typeface="+mn-ea"/>
-        <a:cs typeface="+mn-cs"/>
-      </a:defRPr>
-    </a:lvl8pPr>
-    <a:lvl9pPr marL="3657600" algn="l" defTabSz="457200" rtl="0" eaLnBrk="1" latinLnBrk="0" hangingPunct="1">
-      <a:defRPr sz="1200" kern="1200">
-        <a:solidFill>
-          <a:schemeClr val="tx1"/>
-        </a:solidFill>
-        <a:latin typeface="+mn-lt"/>
-        <a:ea typeface="+mn-ea"/>
-        <a:cs typeface="+mn-cs"/>
-      </a:defRPr>
-    </a:lvl9pPr>
-  </p:notesStyle>
-</p:notesMaster>
-</file>
-
-<file path=ppt/notesSlides/notesSlide1.xml><?xml version="1.0" encoding="utf-8"?>
-<p:notes xmlns:a="http://schemas.openxmlformats.org/drawingml/2006/main" xmlns:p="http://schemas.openxmlformats.org/presentationml/2006/main" xmlns:r="http://schemas.openxmlformats.org/officeDocument/2006/relationships">
-  <p:cSld>
-    <p:spTree>
-      <p:nvGrpSpPr>
-        <p:cNvPr id="1" name=""/>
-        <p:cNvGrpSpPr/>
-        <p:nvPr/>
-      </p:nvGrpSpPr>
-      <p:grpSpPr>
-        <a:xfrm>
-          <a:off x="0" y="0"/>
-          <a:ext cx="0" cy="0"/>
-          <a:chOff x="0" y="0"/>
-          <a:chExt cx="0" cy="0"/>
-        </a:xfrm>
-      </p:grpSpPr>
-      <p:sp>
-        <p:nvSpPr>
-          <p:cNvPr id="2" name="Slide Image Placeholder 1"/>
-          <p:cNvSpPr>
-            <a:spLocks noGrp="1"/>
-          </p:cNvSpPr>
-          <p:nvPr>
-            <p:ph type="sldImg" idx="2"/>
-          </p:nvPr>
-        </p:nvSpPr>
-        <p:spPr/>
-      </p:sp>
-      <p:sp>
-        <p:nvSpPr>
-          <p:cNvPr id="3" name="Notes Placeholder 2"/>
-          <p:cNvSpPr>
-            <a:spLocks noGrp="1"/>
-          </p:cNvSpPr>
-          <p:nvPr>
-            <p:ph type="body" idx="3" sz="quarter"/>
-          </p:nvPr>
-        </p:nvSpPr>
-        <p:spPr/>
-        <p:txBody>
-          <a:bodyPr/>
-          <a:lstStyle/>
-          <a:p>
-            <a:r>
-              <a:t>Good morning judges. We are presenting the Satellite Flood Risk &amp; Relief Monitor. Our team combines satellite data engineering, real-time spatial pathfinding, and GIS risk modeling to solve critical disaster management bottlenecks.</a:t>
-            </a:r>
-          </a:p>
-        </p:txBody>
-      </p:sp>
-      <p:sp>
-        <p:nvSpPr>
-          <p:cNvPr id="4" name="Slide Number Placeholder 3"/>
-          <p:cNvSpPr>
-            <a:spLocks noGrp="1"/>
-          </p:cNvSpPr>
-          <p:nvPr>
-            <p:ph type="sldNum" idx="5" sz="quarter"/>
-          </p:nvPr>
-        </p:nvSpPr>
-        <p:spPr/>
-      </p:sp>
-    </p:spTree>
-  </p:cSld>
-  <p:clrMapOvr>
-    <a:masterClrMapping/>
-  </p:clrMapOvr>
-</p:notes>
-</file>
-
-<file path=ppt/notesSlides/notesSlide10.xml><?xml version="1.0" encoding="utf-8"?>
-<p:notes xmlns:a="http://schemas.openxmlformats.org/drawingml/2006/main" xmlns:p="http://schemas.openxmlformats.org/presentationml/2006/main" xmlns:r="http://schemas.openxmlformats.org/officeDocument/2006/relationships">
-  <p:cSld>
-    <p:spTree>
-      <p:nvGrpSpPr>
-        <p:cNvPr id="1" name=""/>
-        <p:cNvGrpSpPr/>
-        <p:nvPr/>
-      </p:nvGrpSpPr>
-      <p:grpSpPr>
-        <a:xfrm>
-          <a:off x="0" y="0"/>
-          <a:ext cx="0" cy="0"/>
-          <a:chOff x="0" y="0"/>
-          <a:chExt cx="0" cy="0"/>
-        </a:xfrm>
-      </p:grpSpPr>
-      <p:sp>
-        <p:nvSpPr>
-          <p:cNvPr id="2" name="Slide Image Placeholder 1"/>
-          <p:cNvSpPr>
-            <a:spLocks noGrp="1"/>
-          </p:cNvSpPr>
-          <p:nvPr>
-            <p:ph type="sldImg" idx="2"/>
-          </p:nvPr>
-        </p:nvSpPr>
-        <p:spPr/>
-      </p:sp>
-      <p:sp>
-        <p:nvSpPr>
-          <p:cNvPr id="3" name="Notes Placeholder 2"/>
-          <p:cNvSpPr>
-            <a:spLocks noGrp="1"/>
-          </p:cNvSpPr>
-          <p:nvPr>
-            <p:ph type="body" idx="3" sz="quarter"/>
-          </p:nvPr>
-        </p:nvSpPr>
-        <p:spPr/>
-        <p:txBody>
-          <a:bodyPr/>
-          <a:lstStyle/>
-          <a:p>
-            <a:r>
-              <a:t>Our technology stack is 100% open-source, spanning Sentinel-1 radar data, Python geospatial processing, QGIS risk analysis, Leaflet.js frontend, OSRM routing, and cloud deployment on Render.</a:t>
-            </a:r>
-          </a:p>
-        </p:txBody>
-      </p:sp>
-      <p:sp>
-        <p:nvSpPr>
-          <p:cNvPr id="4" name="Slide Number Placeholder 3"/>
-          <p:cNvSpPr>
-            <a:spLocks noGrp="1"/>
-          </p:cNvSpPr>
-          <p:nvPr>
-            <p:ph type="sldNum" idx="5" sz="quarter"/>
-          </p:nvPr>
-        </p:nvSpPr>
-        <p:spPr/>
-      </p:sp>
-    </p:spTree>
-  </p:cSld>
-  <p:clrMapOvr>
-    <a:masterClrMapping/>
-  </p:clrMapOvr>
-</p:notes>
-</file>
-
-<file path=ppt/notesSlides/notesSlide11.xml><?xml version="1.0" encoding="utf-8"?>
-<p:notes xmlns:a="http://schemas.openxmlformats.org/drawingml/2006/main" xmlns:p="http://schemas.openxmlformats.org/presentationml/2006/main" xmlns:r="http://schemas.openxmlformats.org/officeDocument/2006/relationships">
-  <p:cSld>
-    <p:spTree>
-      <p:nvGrpSpPr>
-        <p:cNvPr id="1" name=""/>
-        <p:cNvGrpSpPr/>
-        <p:nvPr/>
-      </p:nvGrpSpPr>
-      <p:grpSpPr>
-        <a:xfrm>
-          <a:off x="0" y="0"/>
-          <a:ext cx="0" cy="0"/>
-          <a:chOff x="0" y="0"/>
-          <a:chExt cx="0" cy="0"/>
-        </a:xfrm>
-      </p:grpSpPr>
-      <p:sp>
-        <p:nvSpPr>
-          <p:cNvPr id="2" name="Slide Image Placeholder 1"/>
-          <p:cNvSpPr>
-            <a:spLocks noGrp="1"/>
-          </p:cNvSpPr>
-          <p:nvPr>
-            <p:ph type="sldImg" idx="2"/>
-          </p:nvPr>
-        </p:nvSpPr>
-        <p:spPr/>
-      </p:sp>
-      <p:sp>
-        <p:nvSpPr>
-          <p:cNvPr id="3" name="Notes Placeholder 2"/>
-          <p:cNvSpPr>
-            <a:spLocks noGrp="1"/>
-          </p:cNvSpPr>
-          <p:nvPr>
-            <p:ph type="body" idx="3" sz="quarter"/>
-          </p:nvPr>
-        </p:nvSpPr>
-        <p:spPr/>
-        <p:txBody>
-          <a:bodyPr/>
-          <a:lstStyle/>
-          <a:p>
-            <a:r>
-              <a:t>Rudra's part: Our solution has zero licensing costs using open data, scales to thousands of concurrent users because spatial math runs in the browser, and costs less than ten dollars a month to operate.</a:t>
-            </a:r>
-          </a:p>
-        </p:txBody>
-      </p:sp>
-      <p:sp>
-        <p:nvSpPr>
-          <p:cNvPr id="4" name="Slide Number Placeholder 3"/>
-          <p:cNvSpPr>
-            <a:spLocks noGrp="1"/>
-          </p:cNvSpPr>
-          <p:nvPr>
-            <p:ph type="sldNum" idx="5" sz="quarter"/>
-          </p:nvPr>
-        </p:nvSpPr>
-        <p:spPr/>
-      </p:sp>
-    </p:spTree>
-  </p:cSld>
-  <p:clrMapOvr>
-    <a:masterClrMapping/>
-  </p:clrMapOvr>
-</p:notes>
-</file>
-
-<file path=ppt/notesSlides/notesSlide12.xml><?xml version="1.0" encoding="utf-8"?>
-<p:notes xmlns:a="http://schemas.openxmlformats.org/drawingml/2006/main" xmlns:p="http://schemas.openxmlformats.org/presentationml/2006/main" xmlns:r="http://schemas.openxmlformats.org/officeDocument/2006/relationships">
-  <p:cSld>
-    <p:spTree>
-      <p:nvGrpSpPr>
-        <p:cNvPr id="1" name=""/>
-        <p:cNvGrpSpPr/>
-        <p:nvPr/>
-      </p:nvGrpSpPr>
-      <p:grpSpPr>
-        <a:xfrm>
-          <a:off x="0" y="0"/>
-          <a:ext cx="0" cy="0"/>
-          <a:chOff x="0" y="0"/>
-          <a:chExt cx="0" cy="0"/>
-        </a:xfrm>
-      </p:grpSpPr>
-      <p:sp>
-        <p:nvSpPr>
-          <p:cNvPr id="2" name="Slide Image Placeholder 1"/>
-          <p:cNvSpPr>
-            <a:spLocks noGrp="1"/>
-          </p:cNvSpPr>
-          <p:nvPr>
-            <p:ph type="sldImg" idx="2"/>
-          </p:nvPr>
-        </p:nvSpPr>
-        <p:spPr/>
-      </p:sp>
-      <p:sp>
-        <p:nvSpPr>
-          <p:cNvPr id="3" name="Notes Placeholder 2"/>
-          <p:cNvSpPr>
-            <a:spLocks noGrp="1"/>
-          </p:cNvSpPr>
-          <p:nvPr>
-            <p:ph type="body" idx="3" sz="quarter"/>
-          </p:nvPr>
-        </p:nvSpPr>
-        <p:spPr/>
-        <p:txBody>
-          <a:bodyPr/>
-          <a:lstStyle/>
-          <a:p>
-            <a:r>
-              <a:t>In conclusion: our platform reduces disaster decision latency from hours to seconds, guarantees first responder safety through dynamic dry routing, and connects community aid directly on the map. We invite the judges to explore the live website.</a:t>
-            </a:r>
-          </a:p>
-        </p:txBody>
-      </p:sp>
-      <p:sp>
-        <p:nvSpPr>
-          <p:cNvPr id="4" name="Slide Number Placeholder 3"/>
-          <p:cNvSpPr>
-            <a:spLocks noGrp="1"/>
-          </p:cNvSpPr>
-          <p:nvPr>
-            <p:ph type="sldNum" idx="5" sz="quarter"/>
-          </p:nvPr>
-        </p:nvSpPr>
-        <p:spPr/>
-      </p:sp>
-    </p:spTree>
-  </p:cSld>
-  <p:clrMapOvr>
-    <a:masterClrMapping/>
-  </p:clrMapOvr>
-</p:notes>
-</file>
-
-<file path=ppt/notesSlides/notesSlide2.xml><?xml version="1.0" encoding="utf-8"?>
-<p:notes xmlns:a="http://schemas.openxmlformats.org/drawingml/2006/main" xmlns:p="http://schemas.openxmlformats.org/presentationml/2006/main" xmlns:r="http://schemas.openxmlformats.org/officeDocument/2006/relationships">
-  <p:cSld>
-    <p:spTree>
-      <p:nvGrpSpPr>
-        <p:cNvPr id="1" name=""/>
-        <p:cNvGrpSpPr/>
-        <p:nvPr/>
-      </p:nvGrpSpPr>
-      <p:grpSpPr>
-        <a:xfrm>
-          <a:off x="0" y="0"/>
-          <a:ext cx="0" cy="0"/>
-          <a:chOff x="0" y="0"/>
-          <a:chExt cx="0" cy="0"/>
-        </a:xfrm>
-      </p:grpSpPr>
-      <p:sp>
-        <p:nvSpPr>
-          <p:cNvPr id="2" name="Slide Image Placeholder 1"/>
-          <p:cNvSpPr>
-            <a:spLocks noGrp="1"/>
-          </p:cNvSpPr>
-          <p:nvPr>
-            <p:ph type="sldImg" idx="2"/>
-          </p:nvPr>
-        </p:nvSpPr>
-        <p:spPr/>
-      </p:sp>
-      <p:sp>
-        <p:nvSpPr>
-          <p:cNvPr id="3" name="Notes Placeholder 2"/>
-          <p:cNvSpPr>
-            <a:spLocks noGrp="1"/>
-          </p:cNvSpPr>
-          <p:nvPr>
-            <p:ph type="body" idx="3" sz="quarter"/>
-          </p:nvPr>
-        </p:nvSpPr>
-        <p:spPr/>
-        <p:txBody>
-          <a:bodyPr/>
-          <a:lstStyle/>
-          <a:p>
-            <a:r>
-              <a:t>In catastrophic events like the Assam floods, standard satellite monitoring fails because clouds block optical sensors. Meanwhile, first responders navigating via standard GPS apps get trapped in floodwaters, and manual GIS maps arrive hours too late.</a:t>
-            </a:r>
-          </a:p>
-        </p:txBody>
-      </p:sp>
-      <p:sp>
-        <p:nvSpPr>
-          <p:cNvPr id="4" name="Slide Number Placeholder 3"/>
-          <p:cNvSpPr>
-            <a:spLocks noGrp="1"/>
-          </p:cNvSpPr>
-          <p:nvPr>
-            <p:ph type="sldNum" idx="5" sz="quarter"/>
-          </p:nvPr>
-        </p:nvSpPr>
-        <p:spPr/>
-      </p:sp>
-    </p:spTree>
-  </p:cSld>
-  <p:clrMapOvr>
-    <a:masterClrMapping/>
-  </p:clrMapOvr>
-</p:notes>
-</file>
-
-<file path=ppt/notesSlides/notesSlide3.xml><?xml version="1.0" encoding="utf-8"?>
-<p:notes xmlns:a="http://schemas.openxmlformats.org/drawingml/2006/main" xmlns:p="http://schemas.openxmlformats.org/presentationml/2006/main" xmlns:r="http://schemas.openxmlformats.org/officeDocument/2006/relationships">
-  <p:cSld>
-    <p:spTree>
-      <p:nvGrpSpPr>
-        <p:cNvPr id="1" name=""/>
-        <p:cNvGrpSpPr/>
-        <p:nvPr/>
-      </p:nvGrpSpPr>
-      <p:grpSpPr>
-        <a:xfrm>
-          <a:off x="0" y="0"/>
-          <a:ext cx="0" cy="0"/>
-          <a:chOff x="0" y="0"/>
-          <a:chExt cx="0" cy="0"/>
-        </a:xfrm>
-      </p:grpSpPr>
-      <p:sp>
-        <p:nvSpPr>
-          <p:cNvPr id="2" name="Slide Image Placeholder 1"/>
-          <p:cNvSpPr>
-            <a:spLocks noGrp="1"/>
-          </p:cNvSpPr>
-          <p:nvPr>
-            <p:ph type="sldImg" idx="2"/>
-          </p:nvPr>
-        </p:nvSpPr>
-        <p:spPr/>
-      </p:sp>
-      <p:sp>
-        <p:nvSpPr>
-          <p:cNvPr id="3" name="Notes Placeholder 2"/>
-          <p:cNvSpPr>
-            <a:spLocks noGrp="1"/>
-          </p:cNvSpPr>
-          <p:nvPr>
-            <p:ph type="body" idx="3" sz="quarter"/>
-          </p:nvPr>
-        </p:nvSpPr>
-        <p:spPr/>
-        <p:txBody>
-          <a:bodyPr/>
-          <a:lstStyle/>
-          <a:p>
-            <a:r>
-              <a:t>Here is our end-to-end architecture. The pipeline automatically checks Copernicus every 60 seconds, runs radar change detection, exposes live REST endpoints, and feeds our Leaflet frontend and Safe Route Finder.</a:t>
-            </a:r>
-          </a:p>
-        </p:txBody>
-      </p:sp>
-      <p:sp>
-        <p:nvSpPr>
-          <p:cNvPr id="4" name="Slide Number Placeholder 3"/>
-          <p:cNvSpPr>
-            <a:spLocks noGrp="1"/>
-          </p:cNvSpPr>
-          <p:nvPr>
-            <p:ph type="sldNum" idx="5" sz="quarter"/>
-          </p:nvPr>
-        </p:nvSpPr>
-        <p:spPr/>
-      </p:sp>
-    </p:spTree>
-  </p:cSld>
-  <p:clrMapOvr>
-    <a:masterClrMapping/>
-  </p:clrMapOvr>
-</p:notes>
-</file>
-
-<file path=ppt/notesSlides/notesSlide4.xml><?xml version="1.0" encoding="utf-8"?>
-<p:notes xmlns:a="http://schemas.openxmlformats.org/drawingml/2006/main" xmlns:p="http://schemas.openxmlformats.org/presentationml/2006/main" xmlns:r="http://schemas.openxmlformats.org/officeDocument/2006/relationships">
-  <p:cSld>
-    <p:spTree>
-      <p:nvGrpSpPr>
-        <p:cNvPr id="1" name=""/>
-        <p:cNvGrpSpPr/>
-        <p:nvPr/>
-      </p:nvGrpSpPr>
-      <p:grpSpPr>
-        <a:xfrm>
-          <a:off x="0" y="0"/>
-          <a:ext cx="0" cy="0"/>
-          <a:chOff x="0" y="0"/>
-          <a:chExt cx="0" cy="0"/>
-        </a:xfrm>
-      </p:grpSpPr>
-      <p:sp>
-        <p:nvSpPr>
-          <p:cNvPr id="2" name="Slide Image Placeholder 1"/>
-          <p:cNvSpPr>
-            <a:spLocks noGrp="1"/>
-          </p:cNvSpPr>
-          <p:nvPr>
-            <p:ph type="sldImg" idx="2"/>
-          </p:nvPr>
-        </p:nvSpPr>
-        <p:spPr/>
-      </p:sp>
-      <p:sp>
-        <p:nvSpPr>
-          <p:cNvPr id="3" name="Notes Placeholder 2"/>
-          <p:cNvSpPr>
-            <a:spLocks noGrp="1"/>
-          </p:cNvSpPr>
-          <p:nvPr>
-            <p:ph type="body" idx="3" sz="quarter"/>
-          </p:nvPr>
-        </p:nvSpPr>
-        <p:spPr/>
-        <p:txBody>
-          <a:bodyPr/>
-          <a:lstStyle/>
-          <a:p>
-            <a:r>
-              <a:t>Nishtha's part: Explaining how Sentinel-1's C-band radar penetrates clouds, how water reflects microwaves away to create dark backscatter deltas, and how our Python pipeline automates ingestion and polygon vectorization.</a:t>
-            </a:r>
-          </a:p>
-        </p:txBody>
-      </p:sp>
-      <p:sp>
-        <p:nvSpPr>
-          <p:cNvPr id="4" name="Slide Number Placeholder 3"/>
-          <p:cNvSpPr>
-            <a:spLocks noGrp="1"/>
-          </p:cNvSpPr>
-          <p:nvPr>
-            <p:ph type="sldNum" idx="5" sz="quarter"/>
-          </p:nvPr>
-        </p:nvSpPr>
-        <p:spPr/>
-      </p:sp>
-    </p:spTree>
-  </p:cSld>
-  <p:clrMapOvr>
-    <a:masterClrMapping/>
-  </p:clrMapOvr>
-</p:notes>
-</file>
-
-<file path=ppt/notesSlides/notesSlide5.xml><?xml version="1.0" encoding="utf-8"?>
-<p:notes xmlns:a="http://schemas.openxmlformats.org/drawingml/2006/main" xmlns:p="http://schemas.openxmlformats.org/presentationml/2006/main" xmlns:r="http://schemas.openxmlformats.org/officeDocument/2006/relationships">
-  <p:cSld>
-    <p:spTree>
-      <p:nvGrpSpPr>
-        <p:cNvPr id="1" name=""/>
-        <p:cNvGrpSpPr/>
-        <p:nvPr/>
-      </p:nvGrpSpPr>
-      <p:grpSpPr>
-        <a:xfrm>
-          <a:off x="0" y="0"/>
-          <a:ext cx="0" cy="0"/>
-          <a:chOff x="0" y="0"/>
-          <a:chExt cx="0" cy="0"/>
-        </a:xfrm>
-      </p:grpSpPr>
-      <p:sp>
-        <p:nvSpPr>
-          <p:cNvPr id="2" name="Slide Image Placeholder 1"/>
-          <p:cNvSpPr>
-            <a:spLocks noGrp="1"/>
-          </p:cNvSpPr>
-          <p:nvPr>
-            <p:ph type="sldImg" idx="2"/>
-          </p:nvPr>
-        </p:nvSpPr>
-        <p:spPr/>
-      </p:sp>
-      <p:sp>
-        <p:nvSpPr>
-          <p:cNvPr id="3" name="Notes Placeholder 2"/>
-          <p:cNvSpPr>
-            <a:spLocks noGrp="1"/>
-          </p:cNvSpPr>
-          <p:nvPr>
-            <p:ph type="body" idx="3" sz="quarter"/>
-          </p:nvPr>
-        </p:nvSpPr>
-        <p:spPr/>
-        <p:txBody>
-          <a:bodyPr/>
-          <a:lstStyle/>
-          <a:p>
-            <a:r>
-              <a:t>Mahathi's part: Presenting the Leaflet dashboard UI/UX, the top navigation switcher between Operations and Satellite views, the high-contrast accessible map legend, and simplified live telemetry.</a:t>
-            </a:r>
-          </a:p>
-        </p:txBody>
-      </p:sp>
-      <p:sp>
-        <p:nvSpPr>
-          <p:cNvPr id="4" name="Slide Number Placeholder 3"/>
-          <p:cNvSpPr>
-            <a:spLocks noGrp="1"/>
-          </p:cNvSpPr>
-          <p:nvPr>
-            <p:ph type="sldNum" idx="5" sz="quarter"/>
-          </p:nvPr>
-        </p:nvSpPr>
-        <p:spPr/>
-      </p:sp>
-    </p:spTree>
-  </p:cSld>
-  <p:clrMapOvr>
-    <a:masterClrMapping/>
-  </p:clrMapOvr>
-</p:notes>
-</file>
-
-<file path=ppt/notesSlides/notesSlide6.xml><?xml version="1.0" encoding="utf-8"?>
-<p:notes xmlns:a="http://schemas.openxmlformats.org/drawingml/2006/main" xmlns:p="http://schemas.openxmlformats.org/presentationml/2006/main" xmlns:r="http://schemas.openxmlformats.org/officeDocument/2006/relationships">
-  <p:cSld>
-    <p:spTree>
-      <p:nvGrpSpPr>
-        <p:cNvPr id="1" name=""/>
-        <p:cNvGrpSpPr/>
-        <p:nvPr/>
-      </p:nvGrpSpPr>
-      <p:grpSpPr>
-        <a:xfrm>
-          <a:off x="0" y="0"/>
-          <a:ext cx="0" cy="0"/>
-          <a:chOff x="0" y="0"/>
-          <a:chExt cx="0" cy="0"/>
-        </a:xfrm>
-      </p:grpSpPr>
-      <p:sp>
-        <p:nvSpPr>
-          <p:cNvPr id="2" name="Slide Image Placeholder 1"/>
-          <p:cNvSpPr>
-            <a:spLocks noGrp="1"/>
-          </p:cNvSpPr>
-          <p:nvPr>
-            <p:ph type="sldImg" idx="2"/>
-          </p:nvPr>
-        </p:nvSpPr>
-        <p:spPr/>
-      </p:sp>
-      <p:sp>
-        <p:nvSpPr>
-          <p:cNvPr id="3" name="Notes Placeholder 2"/>
-          <p:cNvSpPr>
-            <a:spLocks noGrp="1"/>
-          </p:cNvSpPr>
-          <p:nvPr>
-            <p:ph type="body" idx="3" sz="quarter"/>
-          </p:nvPr>
-        </p:nvSpPr>
-        <p:spPr/>
-        <p:txBody>
-          <a:bodyPr/>
-          <a:lstStyle/>
-          <a:p>
-            <a:r>
-              <a:t>Mahathi's part: Demonstrating how our routing engine tests roads against flood polygons, dynamically detours around submerged areas, and utilizes spatial indexing to compute safe routes in under 2 milliseconds.</a:t>
-            </a:r>
-          </a:p>
-        </p:txBody>
-      </p:sp>
-      <p:sp>
-        <p:nvSpPr>
-          <p:cNvPr id="4" name="Slide Number Placeholder 3"/>
-          <p:cNvSpPr>
-            <a:spLocks noGrp="1"/>
-          </p:cNvSpPr>
-          <p:nvPr>
-            <p:ph type="sldNum" idx="5" sz="quarter"/>
-          </p:nvPr>
-        </p:nvSpPr>
-        <p:spPr/>
-      </p:sp>
-    </p:spTree>
-  </p:cSld>
-  <p:clrMapOvr>
-    <a:masterClrMapping/>
-  </p:clrMapOvr>
-</p:notes>
-</file>
-
-<file path=ppt/notesSlides/notesSlide7.xml><?xml version="1.0" encoding="utf-8"?>
-<p:notes xmlns:a="http://schemas.openxmlformats.org/drawingml/2006/main" xmlns:p="http://schemas.openxmlformats.org/presentationml/2006/main" xmlns:r="http://schemas.openxmlformats.org/officeDocument/2006/relationships">
-  <p:cSld>
-    <p:spTree>
-      <p:nvGrpSpPr>
-        <p:cNvPr id="1" name=""/>
-        <p:cNvGrpSpPr/>
-        <p:nvPr/>
-      </p:nvGrpSpPr>
-      <p:grpSpPr>
-        <a:xfrm>
-          <a:off x="0" y="0"/>
-          <a:ext cx="0" cy="0"/>
-          <a:chOff x="0" y="0"/>
-          <a:chExt cx="0" cy="0"/>
-        </a:xfrm>
-      </p:grpSpPr>
-      <p:sp>
-        <p:nvSpPr>
-          <p:cNvPr id="2" name="Slide Image Placeholder 1"/>
-          <p:cNvSpPr>
-            <a:spLocks noGrp="1"/>
-          </p:cNvSpPr>
-          <p:nvPr>
-            <p:ph type="sldImg" idx="2"/>
-          </p:nvPr>
-        </p:nvSpPr>
-        <p:spPr/>
-      </p:sp>
-      <p:sp>
-        <p:nvSpPr>
-          <p:cNvPr id="3" name="Notes Placeholder 2"/>
-          <p:cNvSpPr>
-            <a:spLocks noGrp="1"/>
-          </p:cNvSpPr>
-          <p:nvPr>
-            <p:ph type="body" idx="3" sz="quarter"/>
-          </p:nvPr>
-        </p:nvSpPr>
-        <p:spPr/>
-        <p:txBody>
-          <a:bodyPr/>
-          <a:lstStyle/>
-          <a:p>
-            <a:r>
-              <a:t>Our Relief Hub connects citizens directly to volunteer supplies on the map, allowing stranded communities to post SOS requests and volunteers to list food, medicine, or boats with direct phone contact.</a:t>
-            </a:r>
-          </a:p>
-        </p:txBody>
-      </p:sp>
-      <p:sp>
-        <p:nvSpPr>
-          <p:cNvPr id="4" name="Slide Number Placeholder 3"/>
-          <p:cNvSpPr>
-            <a:spLocks noGrp="1"/>
-          </p:cNvSpPr>
-          <p:nvPr>
-            <p:ph type="sldNum" idx="5" sz="quarter"/>
-          </p:nvPr>
-        </p:nvSpPr>
-        <p:spPr/>
-      </p:sp>
-    </p:spTree>
-  </p:cSld>
-  <p:clrMapOvr>
-    <a:masterClrMapping/>
-  </p:clrMapOvr>
-</p:notes>
-</file>
-
-<file path=ppt/notesSlides/notesSlide8.xml><?xml version="1.0" encoding="utf-8"?>
-<p:notes xmlns:a="http://schemas.openxmlformats.org/drawingml/2006/main" xmlns:p="http://schemas.openxmlformats.org/presentationml/2006/main" xmlns:r="http://schemas.openxmlformats.org/officeDocument/2006/relationships">
-  <p:cSld>
-    <p:spTree>
-      <p:nvGrpSpPr>
-        <p:cNvPr id="1" name=""/>
-        <p:cNvGrpSpPr/>
-        <p:nvPr/>
-      </p:nvGrpSpPr>
-      <p:grpSpPr>
-        <a:xfrm>
-          <a:off x="0" y="0"/>
-          <a:ext cx="0" cy="0"/>
-          <a:chOff x="0" y="0"/>
-          <a:chExt cx="0" cy="0"/>
-        </a:xfrm>
-      </p:grpSpPr>
-      <p:sp>
-        <p:nvSpPr>
-          <p:cNvPr id="2" name="Slide Image Placeholder 1"/>
-          <p:cNvSpPr>
-            <a:spLocks noGrp="1"/>
-          </p:cNvSpPr>
-          <p:nvPr>
-            <p:ph type="sldImg" idx="2"/>
-          </p:nvPr>
-        </p:nvSpPr>
-        <p:spPr/>
-      </p:sp>
-      <p:sp>
-        <p:nvSpPr>
-          <p:cNvPr id="3" name="Notes Placeholder 2"/>
-          <p:cNvSpPr>
-            <a:spLocks noGrp="1"/>
-          </p:cNvSpPr>
-          <p:nvPr>
-            <p:ph type="body" idx="3" sz="quarter"/>
-          </p:nvPr>
-        </p:nvSpPr>
-        <p:spPr/>
-        <p:txBody>
-          <a:bodyPr/>
-          <a:lstStyle/>
-          <a:p>
-            <a:r>
-              <a:t>Rudra's part: Explaining our QGIS multi-criteria hazard scoring, how we categorized 660 km² of land into high/medium/low risk, and how we proactively protect 20+ hospitals and key road corridors.</a:t>
-            </a:r>
-          </a:p>
-        </p:txBody>
-      </p:sp>
-      <p:sp>
-        <p:nvSpPr>
-          <p:cNvPr id="4" name="Slide Number Placeholder 3"/>
-          <p:cNvSpPr>
-            <a:spLocks noGrp="1"/>
-          </p:cNvSpPr>
-          <p:nvPr>
-            <p:ph type="sldNum" idx="5" sz="quarter"/>
-          </p:nvPr>
-        </p:nvSpPr>
-        <p:spPr/>
-      </p:sp>
-    </p:spTree>
-  </p:cSld>
-  <p:clrMapOvr>
-    <a:masterClrMapping/>
-  </p:clrMapOvr>
-</p:notes>
-</file>
-
-<file path=ppt/notesSlides/notesSlide9.xml><?xml version="1.0" encoding="utf-8"?>
-<p:notes xmlns:a="http://schemas.openxmlformats.org/drawingml/2006/main" xmlns:p="http://schemas.openxmlformats.org/presentationml/2006/main" xmlns:r="http://schemas.openxmlformats.org/officeDocument/2006/relationships">
-  <p:cSld>
-    <p:spTree>
-      <p:nvGrpSpPr>
-        <p:cNvPr id="1" name=""/>
-        <p:cNvGrpSpPr/>
-        <p:nvPr/>
-      </p:nvGrpSpPr>
-      <p:grpSpPr>
-        <a:xfrm>
-          <a:off x="0" y="0"/>
-          <a:ext cx="0" cy="0"/>
-          <a:chOff x="0" y="0"/>
-          <a:chExt cx="0" cy="0"/>
-        </a:xfrm>
-      </p:grpSpPr>
-      <p:sp>
-        <p:nvSpPr>
-          <p:cNvPr id="2" name="Slide Image Placeholder 1"/>
-          <p:cNvSpPr>
-            <a:spLocks noGrp="1"/>
-          </p:cNvSpPr>
-          <p:nvPr>
-            <p:ph type="sldImg" idx="2"/>
-          </p:nvPr>
-        </p:nvSpPr>
-        <p:spPr/>
-      </p:sp>
-      <p:sp>
-        <p:nvSpPr>
-          <p:cNvPr id="3" name="Notes Placeholder 2"/>
-          <p:cNvSpPr>
-            <a:spLocks noGrp="1"/>
-          </p:cNvSpPr>
-          <p:nvPr>
-            <p:ph type="body" idx="3" sz="quarter"/>
-          </p:nvPr>
-        </p:nvSpPr>
-        <p:spPr/>
-        <p:txBody>
-          <a:bodyPr/>
-          <a:lstStyle/>
-          <a:p>
-            <a:r>
-              <a:t>In the Satellite Analytics portal, users can inspect high-resolution SAR captures comparing pre-flood baseline vs peak inundation, the change detection heatmap, and the resulting cleaned vector mask.</a:t>
-            </a:r>
-          </a:p>
-        </p:txBody>
-      </p:sp>
-      <p:sp>
-        <p:nvSpPr>
-          <p:cNvPr id="4" name="Slide Number Placeholder 3"/>
-          <p:cNvSpPr>
-            <a:spLocks noGrp="1"/>
-          </p:cNvSpPr>
-          <p:nvPr>
-            <p:ph type="sldNum" idx="5" sz="quarter"/>
-          </p:nvPr>
-        </p:nvSpPr>
-        <p:spPr/>
-      </p:sp>
-    </p:spTree>
-  </p:cSld>
-  <p:clrMapOvr>
-    <a:masterClrMapping/>
-  </p:clrMapOvr>
-</p:notes>
 </file>
 
 <file path=ppt/slideLayouts/slideLayout1.xml><?xml version="1.0" encoding="utf-8"?>
@@ -4306,7 +3116,7 @@
         <p:spPr>
           <a:xfrm>
             <a:off x="731520" y="822960"/>
-            <a:ext cx="4114800" cy="365760"/>
+            <a:ext cx="4389120" cy="365760"/>
           </a:xfrm>
           <a:prstGeom prst="roundRect">
             <a:avLst/>
@@ -4314,7 +3124,7 @@
           <a:solidFill>
             <a:srgbClr val="1E293B"/>
           </a:solidFill>
-          <a:ln>
+          <a:ln w="12700">
             <a:solidFill>
               <a:srgbClr val="0284C7"/>
             </a:solidFill>
@@ -4463,7 +3273,7 @@
           <a:noFill/>
         </p:spPr>
         <p:txBody>
-          <a:bodyPr wrap="square" lIns="0" tIns="0" rIns="0" bIns="0">
+          <a:bodyPr wrap="square">
             <a:spAutoFit/>
           </a:bodyPr>
           <a:lstStyle/>
@@ -4578,7 +3388,7 @@
           <a:noFill/>
         </p:spPr>
         <p:txBody>
-          <a:bodyPr wrap="square" lIns="0" tIns="0" rIns="0" bIns="0">
+          <a:bodyPr wrap="square">
             <a:spAutoFit/>
           </a:bodyPr>
           <a:lstStyle/>
@@ -4693,7 +3503,7 @@
           <a:noFill/>
         </p:spPr>
         <p:txBody>
-          <a:bodyPr wrap="square" lIns="0" tIns="0" rIns="0" bIns="0">
+          <a:bodyPr wrap="square">
             <a:spAutoFit/>
           </a:bodyPr>
           <a:lstStyle/>
@@ -4824,7 +3634,7 @@
           <a:noFill/>
         </p:spPr>
         <p:txBody>
-          <a:bodyPr wrap="square" lIns="0" tIns="0" rIns="0" bIns="0">
+          <a:bodyPr wrap="square">
             <a:spAutoFit/>
           </a:bodyPr>
           <a:lstStyle/>
@@ -4859,7 +3669,7 @@
           <a:noFill/>
         </p:spPr>
         <p:txBody>
-          <a:bodyPr wrap="square" lIns="0" tIns="0" rIns="0" bIns="0">
+          <a:bodyPr wrap="square">
             <a:spAutoFit/>
           </a:bodyPr>
           <a:lstStyle/>
@@ -4939,7 +3749,7 @@
           <a:noFill/>
         </p:spPr>
         <p:txBody>
-          <a:bodyPr wrap="square" lIns="0" tIns="0" rIns="0" bIns="0">
+          <a:bodyPr wrap="square">
             <a:spAutoFit/>
           </a:bodyPr>
           <a:lstStyle/>
@@ -5034,7 +3844,7 @@
           <a:noFill/>
         </p:spPr>
         <p:txBody>
-          <a:bodyPr wrap="square" lIns="0" tIns="0" rIns="0" bIns="0">
+          <a:bodyPr wrap="square">
             <a:spAutoFit/>
           </a:bodyPr>
           <a:lstStyle/>
@@ -5129,7 +3939,7 @@
           <a:noFill/>
         </p:spPr>
         <p:txBody>
-          <a:bodyPr wrap="square" lIns="0" tIns="0" rIns="0" bIns="0">
+          <a:bodyPr wrap="square">
             <a:spAutoFit/>
           </a:bodyPr>
           <a:lstStyle/>
@@ -5224,7 +4034,7 @@
           <a:noFill/>
         </p:spPr>
         <p:txBody>
-          <a:bodyPr wrap="square" lIns="0" tIns="0" rIns="0" bIns="0">
+          <a:bodyPr wrap="square">
             <a:spAutoFit/>
           </a:bodyPr>
           <a:lstStyle/>
@@ -5300,7 +4110,7 @@
           <a:noFill/>
         </p:spPr>
         <p:txBody>
-          <a:bodyPr wrap="square" lIns="0" tIns="0" rIns="0" bIns="0">
+          <a:bodyPr wrap="square">
             <a:spAutoFit/>
           </a:bodyPr>
           <a:lstStyle/>
@@ -5335,7 +4145,7 @@
           <a:noFill/>
         </p:spPr>
         <p:txBody>
-          <a:bodyPr wrap="square" lIns="0" tIns="0" rIns="0" bIns="0">
+          <a:bodyPr wrap="square">
             <a:spAutoFit/>
           </a:bodyPr>
           <a:lstStyle/>
@@ -5415,7 +4225,7 @@
           <a:noFill/>
         </p:spPr>
         <p:txBody>
-          <a:bodyPr wrap="square" lIns="0" tIns="0" rIns="0" bIns="0">
+          <a:bodyPr wrap="square">
             <a:spAutoFit/>
           </a:bodyPr>
           <a:lstStyle/>
@@ -5549,7 +4359,7 @@
           <a:noFill/>
         </p:spPr>
         <p:txBody>
-          <a:bodyPr wrap="square" lIns="0" tIns="0" rIns="0" bIns="0">
+          <a:bodyPr wrap="square">
             <a:spAutoFit/>
           </a:bodyPr>
           <a:lstStyle/>
@@ -5683,7 +4493,7 @@
           <a:noFill/>
         </p:spPr>
         <p:txBody>
-          <a:bodyPr wrap="square" lIns="0" tIns="0" rIns="0" bIns="0">
+          <a:bodyPr wrap="square">
             <a:spAutoFit/>
           </a:bodyPr>
           <a:lstStyle/>
@@ -5893,7 +4703,7 @@
           <a:noFill/>
         </p:spPr>
         <p:txBody>
-          <a:bodyPr wrap="square" lIns="0" tIns="0" rIns="0" bIns="0">
+          <a:bodyPr wrap="square">
             <a:spAutoFit/>
           </a:bodyPr>
           <a:lstStyle/>
@@ -6000,7 +4810,7 @@
           <a:noFill/>
         </p:spPr>
         <p:txBody>
-          <a:bodyPr wrap="square" lIns="0" tIns="0" rIns="0" bIns="0">
+          <a:bodyPr wrap="square">
             <a:spAutoFit/>
           </a:bodyPr>
           <a:lstStyle/>
@@ -6107,7 +4917,7 @@
           <a:noFill/>
         </p:spPr>
         <p:txBody>
-          <a:bodyPr wrap="square" lIns="0" tIns="0" rIns="0" bIns="0">
+          <a:bodyPr wrap="square">
             <a:spAutoFit/>
           </a:bodyPr>
           <a:lstStyle/>
@@ -6230,7 +5040,7 @@
           <a:noFill/>
         </p:spPr>
         <p:txBody>
-          <a:bodyPr wrap="square" lIns="0" tIns="0" rIns="0" bIns="0">
+          <a:bodyPr wrap="square">
             <a:spAutoFit/>
           </a:bodyPr>
           <a:lstStyle/>
@@ -6265,7 +5075,7 @@
           <a:noFill/>
         </p:spPr>
         <p:txBody>
-          <a:bodyPr wrap="square" lIns="0" tIns="0" rIns="0" bIns="0">
+          <a:bodyPr wrap="square">
             <a:spAutoFit/>
           </a:bodyPr>
           <a:lstStyle/>
@@ -6345,7 +5155,7 @@
           <a:noFill/>
         </p:spPr>
         <p:txBody>
-          <a:bodyPr wrap="square" lIns="0" tIns="0" rIns="0" bIns="0">
+          <a:bodyPr wrap="square">
             <a:spAutoFit/>
           </a:bodyPr>
           <a:lstStyle/>
@@ -6440,7 +5250,7 @@
           <a:noFill/>
         </p:spPr>
         <p:txBody>
-          <a:bodyPr wrap="square" lIns="0" tIns="0" rIns="0" bIns="0">
+          <a:bodyPr wrap="square">
             <a:spAutoFit/>
           </a:bodyPr>
           <a:lstStyle/>
@@ -6535,7 +5345,7 @@
           <a:noFill/>
         </p:spPr>
         <p:txBody>
-          <a:bodyPr wrap="square" lIns="0" tIns="0" rIns="0" bIns="0">
+          <a:bodyPr wrap="square">
             <a:spAutoFit/>
           </a:bodyPr>
           <a:lstStyle/>
@@ -6630,7 +5440,7 @@
           <a:noFill/>
         </p:spPr>
         <p:txBody>
-          <a:bodyPr wrap="square" lIns="0" tIns="0" rIns="0" bIns="0">
+          <a:bodyPr wrap="square">
             <a:spAutoFit/>
           </a:bodyPr>
           <a:lstStyle/>
@@ -6706,7 +5516,7 @@
           <a:noFill/>
         </p:spPr>
         <p:txBody>
-          <a:bodyPr wrap="square" lIns="0" tIns="0" rIns="0" bIns="0">
+          <a:bodyPr wrap="square">
             <a:spAutoFit/>
           </a:bodyPr>
           <a:lstStyle/>
@@ -6741,7 +5551,7 @@
           <a:noFill/>
         </p:spPr>
         <p:txBody>
-          <a:bodyPr wrap="square" lIns="0" tIns="0" rIns="0" bIns="0">
+          <a:bodyPr wrap="square">
             <a:spAutoFit/>
           </a:bodyPr>
           <a:lstStyle/>
@@ -6821,7 +5631,7 @@
           <a:noFill/>
         </p:spPr>
         <p:txBody>
-          <a:bodyPr wrap="square" lIns="0" tIns="0" rIns="0" bIns="0">
+          <a:bodyPr wrap="square">
             <a:spAutoFit/>
           </a:bodyPr>
           <a:lstStyle/>
@@ -6975,7 +5785,7 @@
           <a:noFill/>
         </p:spPr>
         <p:txBody>
-          <a:bodyPr wrap="square" lIns="0" tIns="0" rIns="0" bIns="0">
+          <a:bodyPr wrap="square">
             <a:spAutoFit/>
           </a:bodyPr>
           <a:lstStyle/>
@@ -7129,7 +5939,7 @@
           <a:noFill/>
         </p:spPr>
         <p:txBody>
-          <a:bodyPr wrap="square" lIns="0" tIns="0" rIns="0" bIns="0">
+          <a:bodyPr wrap="square">
             <a:spAutoFit/>
           </a:bodyPr>
           <a:lstStyle/>
@@ -7260,7 +6070,7 @@
           <a:noFill/>
         </p:spPr>
         <p:txBody>
-          <a:bodyPr wrap="square" lIns="0" tIns="0" rIns="0" bIns="0">
+          <a:bodyPr wrap="square">
             <a:spAutoFit/>
           </a:bodyPr>
           <a:lstStyle/>
@@ -7295,7 +6105,7 @@
           <a:noFill/>
         </p:spPr>
         <p:txBody>
-          <a:bodyPr wrap="square" lIns="0" tIns="0" rIns="0" bIns="0">
+          <a:bodyPr wrap="square">
             <a:spAutoFit/>
           </a:bodyPr>
           <a:lstStyle/>
@@ -7375,7 +6185,7 @@
           <a:noFill/>
         </p:spPr>
         <p:txBody>
-          <a:bodyPr wrap="square" lIns="0" tIns="0" rIns="0" bIns="0">
+          <a:bodyPr wrap="square">
             <a:spAutoFit/>
           </a:bodyPr>
           <a:lstStyle/>
@@ -7494,7 +6304,7 @@
           <a:noFill/>
         </p:spPr>
         <p:txBody>
-          <a:bodyPr wrap="square" lIns="0" tIns="0" rIns="0" bIns="0">
+          <a:bodyPr wrap="square">
             <a:spAutoFit/>
           </a:bodyPr>
           <a:lstStyle/>
@@ -7594,7 +6404,7 @@
           <a:noFill/>
         </p:spPr>
         <p:txBody>
-          <a:bodyPr wrap="square" lIns="0" tIns="0" rIns="0" bIns="0">
+          <a:bodyPr wrap="square">
             <a:spAutoFit/>
           </a:bodyPr>
           <a:lstStyle/>
@@ -7629,7 +6439,7 @@
           <a:noFill/>
         </p:spPr>
         <p:txBody>
-          <a:bodyPr wrap="square" lIns="0" tIns="0" rIns="0" bIns="0">
+          <a:bodyPr wrap="square">
             <a:spAutoFit/>
           </a:bodyPr>
           <a:lstStyle/>
@@ -7709,7 +6519,7 @@
           <a:noFill/>
         </p:spPr>
         <p:txBody>
-          <a:bodyPr wrap="square" lIns="0" tIns="0" rIns="0" bIns="0">
+          <a:bodyPr wrap="square">
             <a:spAutoFit/>
           </a:bodyPr>
           <a:lstStyle/>
@@ -7843,7 +6653,7 @@
           <a:noFill/>
         </p:spPr>
         <p:txBody>
-          <a:bodyPr wrap="square" lIns="0" tIns="0" rIns="0" bIns="0">
+          <a:bodyPr wrap="square">
             <a:spAutoFit/>
           </a:bodyPr>
           <a:lstStyle/>
@@ -7977,7 +6787,7 @@
           <a:noFill/>
         </p:spPr>
         <p:txBody>
-          <a:bodyPr wrap="square" lIns="0" tIns="0" rIns="0" bIns="0">
+          <a:bodyPr wrap="square">
             <a:spAutoFit/>
           </a:bodyPr>
           <a:lstStyle/>
@@ -8092,7 +6902,7 @@
           <a:noFill/>
         </p:spPr>
         <p:txBody>
-          <a:bodyPr wrap="square" lIns="0" tIns="0" rIns="0" bIns="0">
+          <a:bodyPr wrap="square">
             <a:spAutoFit/>
           </a:bodyPr>
           <a:lstStyle/>
@@ -8127,7 +6937,7 @@
           <a:noFill/>
         </p:spPr>
         <p:txBody>
-          <a:bodyPr wrap="square" lIns="0" tIns="0" rIns="0" bIns="0">
+          <a:bodyPr wrap="square">
             <a:spAutoFit/>
           </a:bodyPr>
           <a:lstStyle/>
@@ -8207,7 +7017,7 @@
           <a:noFill/>
         </p:spPr>
         <p:txBody>
-          <a:bodyPr wrap="square" lIns="0" tIns="0" rIns="0" bIns="0">
+          <a:bodyPr wrap="square">
             <a:spAutoFit/>
           </a:bodyPr>
           <a:lstStyle/>
@@ -8368,7 +7178,7 @@
           <a:noFill/>
         </p:spPr>
         <p:txBody>
-          <a:bodyPr wrap="square" lIns="0" tIns="0" rIns="0" bIns="0">
+          <a:bodyPr wrap="square">
             <a:spAutoFit/>
           </a:bodyPr>
           <a:lstStyle/>
@@ -8510,7 +7320,7 @@
           <a:noFill/>
         </p:spPr>
         <p:txBody>
-          <a:bodyPr wrap="square" lIns="0" tIns="0" rIns="0" bIns="0">
+          <a:bodyPr wrap="square">
             <a:spAutoFit/>
           </a:bodyPr>
           <a:lstStyle/>
@@ -8545,7 +7355,7 @@
           <a:noFill/>
         </p:spPr>
         <p:txBody>
-          <a:bodyPr wrap="square" lIns="0" tIns="0" rIns="0" bIns="0">
+          <a:bodyPr wrap="square">
             <a:spAutoFit/>
           </a:bodyPr>
           <a:lstStyle/>
@@ -8625,7 +7435,7 @@
           <a:noFill/>
         </p:spPr>
         <p:txBody>
-          <a:bodyPr wrap="square" lIns="0" tIns="0" rIns="0" bIns="0">
+          <a:bodyPr wrap="square">
             <a:spAutoFit/>
           </a:bodyPr>
           <a:lstStyle/>
@@ -8775,7 +7585,7 @@
           <a:noFill/>
         </p:spPr>
         <p:txBody>
-          <a:bodyPr wrap="square" lIns="0" tIns="0" rIns="0" bIns="0">
+          <a:bodyPr wrap="square">
             <a:spAutoFit/>
           </a:bodyPr>
           <a:lstStyle/>
@@ -8925,7 +7735,7 @@
           <a:noFill/>
         </p:spPr>
         <p:txBody>
-          <a:bodyPr wrap="square" lIns="0" tIns="0" rIns="0" bIns="0">
+          <a:bodyPr wrap="square">
             <a:spAutoFit/>
           </a:bodyPr>
           <a:lstStyle/>
@@ -9040,7 +7850,7 @@
           <a:noFill/>
         </p:spPr>
         <p:txBody>
-          <a:bodyPr wrap="square" lIns="0" tIns="0" rIns="0" bIns="0">
+          <a:bodyPr wrap="square">
             <a:spAutoFit/>
           </a:bodyPr>
           <a:lstStyle/>
@@ -9075,7 +7885,7 @@
           <a:noFill/>
         </p:spPr>
         <p:txBody>
-          <a:bodyPr wrap="square" lIns="0" tIns="0" rIns="0" bIns="0">
+          <a:bodyPr wrap="square">
             <a:spAutoFit/>
           </a:bodyPr>
           <a:lstStyle/>
@@ -9155,7 +7965,7 @@
           <a:noFill/>
         </p:spPr>
         <p:txBody>
-          <a:bodyPr wrap="square" lIns="0" tIns="0" rIns="0" bIns="0">
+          <a:bodyPr wrap="square">
             <a:spAutoFit/>
           </a:bodyPr>
           <a:lstStyle/>
@@ -9311,7 +8121,7 @@
           <a:noFill/>
         </p:spPr>
         <p:txBody>
-          <a:bodyPr wrap="square" lIns="0" tIns="0" rIns="0" bIns="0">
+          <a:bodyPr wrap="square">
             <a:spAutoFit/>
           </a:bodyPr>
           <a:lstStyle/>
@@ -9453,7 +8263,7 @@
           <a:noFill/>
         </p:spPr>
         <p:txBody>
-          <a:bodyPr wrap="square" lIns="0" tIns="0" rIns="0" bIns="0">
+          <a:bodyPr wrap="square">
             <a:spAutoFit/>
           </a:bodyPr>
           <a:lstStyle/>
@@ -9488,7 +8298,7 @@
           <a:noFill/>
         </p:spPr>
         <p:txBody>
-          <a:bodyPr wrap="square" lIns="0" tIns="0" rIns="0" bIns="0">
+          <a:bodyPr wrap="square">
             <a:spAutoFit/>
           </a:bodyPr>
           <a:lstStyle/>
@@ -9568,7 +8378,7 @@
           <a:noFill/>
         </p:spPr>
         <p:txBody>
-          <a:bodyPr wrap="square" lIns="0" tIns="0" rIns="0" bIns="0">
+          <a:bodyPr wrap="square">
             <a:spAutoFit/>
           </a:bodyPr>
           <a:lstStyle/>
@@ -9687,7 +8497,7 @@
           <a:noFill/>
         </p:spPr>
         <p:txBody>
-          <a:bodyPr wrap="square" lIns="0" tIns="0" rIns="0" bIns="0">
+          <a:bodyPr wrap="square">
             <a:spAutoFit/>
           </a:bodyPr>
           <a:lstStyle/>
@@ -9806,7 +8616,7 @@
           <a:noFill/>
         </p:spPr>
         <p:txBody>
-          <a:bodyPr wrap="square" lIns="0" tIns="0" rIns="0" bIns="0">
+          <a:bodyPr wrap="square">
             <a:spAutoFit/>
           </a:bodyPr>
           <a:lstStyle/>
@@ -9921,7 +8731,7 @@
           <a:noFill/>
         </p:spPr>
         <p:txBody>
-          <a:bodyPr wrap="square" lIns="0" tIns="0" rIns="0" bIns="0">
+          <a:bodyPr wrap="square">
             <a:spAutoFit/>
           </a:bodyPr>
           <a:lstStyle/>
@@ -10300,324 +9110,4 @@
   </a:objectDefaults>
   <a:extraClrSchemeLst/>
 </a:theme>
-</file>
-
-<file path=ppt/theme/theme2.xml><?xml version="1.0" encoding="utf-8"?>
-<a:theme xmlns:a="http://schemas.openxmlformats.org/drawingml/2006/main" name="Office Theme">
-  <a:themeElements>
-    <a:clrScheme name="Office">
-      <a:dk1>
-        <a:sysClr val="windowText" lastClr="000000"/>
-      </a:dk1>
-      <a:lt1>
-        <a:sysClr val="window" lastClr="FFFFFF"/>
-      </a:lt1>
-      <a:dk2>
-        <a:srgbClr val="1F497D"/>
-      </a:dk2>
-      <a:lt2>
-        <a:srgbClr val="EEECE1"/>
-      </a:lt2>
-      <a:accent1>
-        <a:srgbClr val="4F81BD"/>
-      </a:accent1>
-      <a:accent2>
-        <a:srgbClr val="C0504D"/>
-      </a:accent2>
-      <a:accent3>
-        <a:srgbClr val="9BBB59"/>
-      </a:accent3>
-      <a:accent4>
-        <a:srgbClr val="8064A2"/>
-      </a:accent4>
-      <a:accent5>
-        <a:srgbClr val="4BACC6"/>
-      </a:accent5>
-      <a:accent6>
-        <a:srgbClr val="F79646"/>
-      </a:accent6>
-      <a:hlink>
-        <a:srgbClr val="0000FF"/>
-      </a:hlink>
-      <a:folHlink>
-        <a:srgbClr val="800080"/>
-      </a:folHlink>
-    </a:clrScheme>
-    <a:fontScheme name="Office">
-      <a:majorFont>
-        <a:latin typeface="Calibri"/>
-        <a:ea typeface=""/>
-        <a:cs typeface=""/>
-        <a:font script="Jpan" typeface="ＭＳ Ｐゴシック"/>
-        <a:font script="Hang" typeface="맑은 고딕"/>
-        <a:font script="Hans" typeface="宋体"/>
-        <a:font script="Hant" typeface="新細明體"/>
-        <a:font script="Arab" typeface="Times New Roman"/>
-        <a:font script="Hebr" typeface="Times New Roman"/>
-        <a:font script="Thai" typeface="Angsana New"/>
-        <a:font script="Ethi" typeface="Nyala"/>
-        <a:font script="Beng" typeface="Vrinda"/>
-        <a:font script="Gujr" typeface="Shruti"/>
-        <a:font script="Khmr" typeface="MoolBoran"/>
-        <a:font script="Knda" typeface="Tunga"/>
-        <a:font script="Guru" typeface="Raavi"/>
-        <a:font script="Cans" typeface="Euphemia"/>
-        <a:font script="Cher" typeface="Plantagenet Cherokee"/>
-        <a:font script="Yiii" typeface="Microsoft Yi Baiti"/>
-        <a:font script="Tibt" typeface="Microsoft Himalaya"/>
-        <a:font script="Thaa" typeface="MV Boli"/>
-        <a:font script="Deva" typeface="Mangal"/>
-        <a:font script="Telu" typeface="Gautami"/>
-        <a:font script="Taml" typeface="Latha"/>
-        <a:font script="Syrc" typeface="Estrangelo Edessa"/>
-        <a:font script="Orya" typeface="Kalinga"/>
-        <a:font script="Mlym" typeface="Kartika"/>
-        <a:font script="Laoo" typeface="DokChampa"/>
-        <a:font script="Sinh" typeface="Iskoola Pota"/>
-        <a:font script="Mong" typeface="Mongolian Baiti"/>
-        <a:font script="Viet" typeface="Times New Roman"/>
-        <a:font script="Uigh" typeface="Microsoft Uighur"/>
-        <a:font script="Geor" typeface="Sylfaen"/>
-      </a:majorFont>
-      <a:minorFont>
-        <a:latin typeface="Calibri"/>
-        <a:ea typeface=""/>
-        <a:cs typeface=""/>
-        <a:font script="Jpan" typeface="ＭＳ Ｐゴシック"/>
-        <a:font script="Hang" typeface="맑은 고딕"/>
-        <a:font script="Hans" typeface="宋体"/>
-        <a:font script="Hant" typeface="新細明體"/>
-        <a:font script="Arab" typeface="Arial"/>
-        <a:font script="Hebr" typeface="Arial"/>
-        <a:font script="Thai" typeface="Cordia New"/>
-        <a:font script="Ethi" typeface="Nyala"/>
-        <a:font script="Beng" typeface="Vrinda"/>
-        <a:font script="Gujr" typeface="Shruti"/>
-        <a:font script="Khmr" typeface="DaunPenh"/>
-        <a:font script="Knda" typeface="Tunga"/>
-        <a:font script="Guru" typeface="Raavi"/>
-        <a:font script="Cans" typeface="Euphemia"/>
-        <a:font script="Cher" typeface="Plantagenet Cherokee"/>
-        <a:font script="Yiii" typeface="Microsoft Yi Baiti"/>
-        <a:font script="Tibt" typeface="Microsoft Himalaya"/>
-        <a:font script="Thaa" typeface="MV Boli"/>
-        <a:font script="Deva" typeface="Mangal"/>
-        <a:font script="Telu" typeface="Gautami"/>
-        <a:font script="Taml" typeface="Latha"/>
-        <a:font script="Syrc" typeface="Estrangelo Edessa"/>
-        <a:font script="Orya" typeface="Kalinga"/>
-        <a:font script="Mlym" typeface="Kartika"/>
-        <a:font script="Laoo" typeface="DokChampa"/>
-        <a:font script="Sinh" typeface="Iskoola Pota"/>
-        <a:font script="Mong" typeface="Mongolian Baiti"/>
-        <a:font script="Viet" typeface="Arial"/>
-        <a:font script="Uigh" typeface="Microsoft Uighur"/>
-        <a:font script="Geor" typeface="Sylfaen"/>
-      </a:minorFont>
-    </a:fontScheme>
-    <a:fmtScheme name="Office">
-      <a:fillStyleLst>
-        <a:solidFill>
-          <a:schemeClr val="phClr"/>
-        </a:solidFill>
-        <a:gradFill rotWithShape="1">
-          <a:gsLst>
-            <a:gs pos="0">
-              <a:schemeClr val="phClr">
-                <a:tint val="50000"/>
-                <a:satMod val="300000"/>
-              </a:schemeClr>
-            </a:gs>
-            <a:gs pos="35000">
-              <a:schemeClr val="phClr">
-                <a:tint val="37000"/>
-                <a:satMod val="300000"/>
-              </a:schemeClr>
-            </a:gs>
-            <a:gs pos="100000">
-              <a:schemeClr val="phClr">
-                <a:tint val="15000"/>
-                <a:satMod val="350000"/>
-              </a:schemeClr>
-            </a:gs>
-          </a:gsLst>
-          <a:lin ang="16200000" scaled="1"/>
-        </a:gradFill>
-        <a:gradFill rotWithShape="1">
-          <a:gsLst>
-            <a:gs pos="0">
-              <a:schemeClr val="phClr">
-                <a:tint val="100000"/>
-                <a:shade val="100000"/>
-                <a:satMod val="130000"/>
-              </a:schemeClr>
-            </a:gs>
-            <a:gs pos="100000">
-              <a:schemeClr val="phClr">
-                <a:tint val="50000"/>
-                <a:shade val="100000"/>
-                <a:satMod val="350000"/>
-              </a:schemeClr>
-            </a:gs>
-          </a:gsLst>
-          <a:lin ang="16200000" scaled="0"/>
-        </a:gradFill>
-      </a:fillStyleLst>
-      <a:lnStyleLst>
-        <a:ln w="9525" cap="flat" cmpd="sng" algn="ctr">
-          <a:solidFill>
-            <a:schemeClr val="phClr">
-              <a:shade val="95000"/>
-              <a:satMod val="105000"/>
-            </a:schemeClr>
-          </a:solidFill>
-          <a:prstDash val="solid"/>
-        </a:ln>
-        <a:ln w="25400" cap="flat" cmpd="sng" algn="ctr">
-          <a:solidFill>
-            <a:schemeClr val="phClr"/>
-          </a:solidFill>
-          <a:prstDash val="solid"/>
-        </a:ln>
-        <a:ln w="38100" cap="flat" cmpd="sng" algn="ctr">
-          <a:solidFill>
-            <a:schemeClr val="phClr"/>
-          </a:solidFill>
-          <a:prstDash val="solid"/>
-        </a:ln>
-      </a:lnStyleLst>
-      <a:effectStyleLst>
-        <a:effectStyle>
-          <a:effectLst>
-            <a:outerShdw blurRad="40000" dist="20000" dir="5400000" rotWithShape="0">
-              <a:srgbClr val="000000">
-                <a:alpha val="38000"/>
-              </a:srgbClr>
-            </a:outerShdw>
-          </a:effectLst>
-        </a:effectStyle>
-        <a:effectStyle>
-          <a:effectLst>
-            <a:outerShdw blurRad="40000" dist="23000" dir="5400000" rotWithShape="0">
-              <a:srgbClr val="000000">
-                <a:alpha val="35000"/>
-              </a:srgbClr>
-            </a:outerShdw>
-          </a:effectLst>
-        </a:effectStyle>
-        <a:effectStyle>
-          <a:effectLst>
-            <a:outerShdw blurRad="40000" dist="23000" dir="5400000" rotWithShape="0">
-              <a:srgbClr val="000000">
-                <a:alpha val="35000"/>
-              </a:srgbClr>
-            </a:outerShdw>
-          </a:effectLst>
-          <a:scene3d>
-            <a:camera prst="orthographicFront">
-              <a:rot lat="0" lon="0" rev="0"/>
-            </a:camera>
-            <a:lightRig rig="threePt" dir="t">
-              <a:rot lat="0" lon="0" rev="1200000"/>
-            </a:lightRig>
-          </a:scene3d>
-          <a:sp3d>
-            <a:bevelT w="63500" h="25400"/>
-          </a:sp3d>
-        </a:effectStyle>
-      </a:effectStyleLst>
-      <a:bgFillStyleLst>
-        <a:solidFill>
-          <a:schemeClr val="phClr"/>
-        </a:solidFill>
-        <a:gradFill rotWithShape="1">
-          <a:gsLst>
-            <a:gs pos="0">
-              <a:schemeClr val="phClr">
-                <a:tint val="40000"/>
-                <a:satMod val="350000"/>
-              </a:schemeClr>
-            </a:gs>
-            <a:gs pos="40000">
-              <a:schemeClr val="phClr">
-                <a:tint val="45000"/>
-                <a:shade val="99000"/>
-                <a:satMod val="350000"/>
-              </a:schemeClr>
-            </a:gs>
-            <a:gs pos="100000">
-              <a:schemeClr val="phClr">
-                <a:shade val="20000"/>
-                <a:satMod val="255000"/>
-              </a:schemeClr>
-            </a:gs>
-          </a:gsLst>
-          <a:path path="circle">
-            <a:fillToRect l="50000" t="-80000" r="50000" b="180000"/>
-          </a:path>
-        </a:gradFill>
-        <a:gradFill rotWithShape="1">
-          <a:gsLst>
-            <a:gs pos="0">
-              <a:schemeClr val="phClr">
-                <a:tint val="80000"/>
-                <a:satMod val="300000"/>
-              </a:schemeClr>
-            </a:gs>
-            <a:gs pos="100000">
-              <a:schemeClr val="phClr">
-                <a:shade val="30000"/>
-                <a:satMod val="200000"/>
-              </a:schemeClr>
-            </a:gs>
-          </a:gsLst>
-          <a:path path="circle">
-            <a:fillToRect l="50000" t="50000" r="50000" b="50000"/>
-          </a:path>
-        </a:gradFill>
-      </a:bgFillStyleLst>
-    </a:fmtScheme>
-  </a:themeElements>
-  <a:objectDefaults>
-    <a:spDef>
-      <a:spPr/>
-      <a:bodyPr/>
-      <a:lstStyle/>
-      <a:style>
-        <a:lnRef idx="1">
-          <a:schemeClr val="accent1"/>
-        </a:lnRef>
-        <a:fillRef idx="3">
-          <a:schemeClr val="accent1"/>
-        </a:fillRef>
-        <a:effectRef idx="2">
-          <a:schemeClr val="accent1"/>
-        </a:effectRef>
-        <a:fontRef idx="minor">
-          <a:schemeClr val="lt1"/>
-        </a:fontRef>
-      </a:style>
-    </a:spDef>
-    <a:lnDef>
-      <a:spPr/>
-      <a:bodyPr/>
-      <a:lstStyle/>
-      <a:style>
-        <a:lnRef idx="2">
-          <a:schemeClr val="accent1"/>
-        </a:lnRef>
-        <a:fillRef idx="0">
-          <a:schemeClr val="accent1"/>
-        </a:fillRef>
-        <a:effectRef idx="1">
-          <a:schemeClr val="accent1"/>
-        </a:effectRef>
-        <a:fontRef idx="minor">
-          <a:schemeClr val="tx1"/>
-        </a:fontRef>
-      </a:style>
-    </a:lnDef>
-  </a:objectDefaults>
-  <a:extraClrSchemeLst/>
-</a:theme>
 </file>
</xml_diff>